<commit_message>
Deck: keep the Privy sign-up stub on 'What actually ran'
Phone-number sign-up being off (Privy SMS for Nigeria) is listed again
alongside UseAzza, so every declared stub stays on the slide.
</commit_message>
<xml_diff>
--- a/docs/deck/nelo-deck.pptx
+++ b/docs/deck/nelo-deck.pptx
@@ -123,30 +123,30 @@
   <p:extLst>
     <p:ext uri="{521415D9-36F7-43E2-AB2F-B90AF26B5E84}">
       <p14:sectionLst xmlns:p14="http://schemas.microsoft.com/office/powerpoint/2010/main">
-        <p14:section name="Opening" id="{76e8caed-be52-508b-fe29-aa8f752290f1}">
+        <p14:section name="Opening" id="{c8adf936-f669-daf5-9cc4-6933fb19fdbe}">
           <p14:sldIdLst>
             <p14:sldId id="256"/>
           </p14:sldIdLst>
         </p14:section>
-        <p14:section name="Problem" id="{7a0041f2-86b9-7d72-2f49-59a01317b942}">
+        <p14:section name="Problem" id="{186b2bf5-dc54-8f00-91a3-5eec7db49e2e}">
           <p14:sldIdLst>
             <p14:sldId id="257"/>
             <p14:sldId id="258"/>
           </p14:sldIdLst>
         </p14:section>
-        <p14:section name="Product" id="{e69e8d8b-277e-b77f-5e1f-e84ab2a0988b}">
+        <p14:section name="Product" id="{2e1b777e-d46a-650d-598b-8f9b4de84ffc}">
           <p14:sldIdLst>
             <p14:sldId id="259"/>
             <p14:sldId id="260"/>
           </p14:sldIdLst>
         </p14:section>
-        <p14:section name="Proof" id="{f4e24fd6-a12f-a04b-1b5e-ac96fba9cc69}">
+        <p14:section name="Proof" id="{7c485117-a664-5c07-f2ce-3ff34ad6704b}">
           <p14:sldIdLst>
             <p14:sldId id="261"/>
             <p14:sldId id="262"/>
           </p14:sldIdLst>
         </p14:section>
-        <p14:section name="Business" id="{0f1b97de-d9a0-c217-4b1d-cd4b42df6dcc}">
+        <p14:section name="Business" id="{a7693e43-437d-9b41-7bd1-79427f7fc48f}">
           <p14:sldIdLst>
             <p14:sldId id="263"/>
             <p14:sldId id="264"/>
@@ -157,7 +157,7 @@
             <p14:sldId id="269"/>
           </p14:sldIdLst>
         </p14:section>
-        <p14:section name="Close" id="{660311cb-1ae8-792a-30c3-7286efc8777e}">
+        <p14:section name="Close" id="{7a184e24-4501-bd4e-e601-f41beb1e4817}">
           <p14:sldIdLst>
             <p14:sldId id="270"/>
             <p14:sldId id="271"/>
@@ -9880,8 +9880,8 @@
         </p:nvSpPr>
         <p:spPr>
           <a:xfrm>
-            <a:off x="822960" y="2606040"/>
-            <a:ext cx="2971800" cy="3063240"/>
+            <a:off x="822960" y="2560320"/>
+            <a:ext cx="2971800" cy="3154680"/>
           </a:xfrm>
           <a:prstGeom prst="rect">
             <a:avLst/>
@@ -9895,74 +9895,74 @@
           <a:p>
             <a:pPr marL="342900" indent="-342900">
               <a:spcAft>
-                <a:spcPts val="800"/>
+                <a:spcPts val="600"/>
               </a:spcAft>
               <a:buSzPct val="100000"/>
               <a:buChar char="•"/>
             </a:pPr>
             <a:r>
-              <a:rPr lang="en-US" sz="1400" dirty="0">
+              <a:rPr lang="en-US" sz="1300" dirty="0">
                 <a:solidFill>
                   <a:schemeClr val="tx1"/>
                 </a:solidFill>
               </a:rPr>
               <a:t>Cash-out on Solana mainnet, paid to a Nigerian bank by paj.cash</a:t>
             </a:r>
-            <a:endParaRPr lang="en-US" sz="1400" dirty="0"/>
+            <a:endParaRPr lang="en-US" sz="1300" dirty="0"/>
           </a:p>
           <a:p>
             <a:pPr marL="342900" indent="-342900">
               <a:spcAft>
-                <a:spcPts val="800"/>
+                <a:spcPts val="600"/>
               </a:spcAft>
               <a:buSzPct val="100000"/>
               <a:buChar char="•"/>
             </a:pPr>
             <a:r>
-              <a:rPr lang="en-US" sz="1400" dirty="0">
+              <a:rPr lang="en-US" sz="1300" dirty="0">
                 <a:solidFill>
                   <a:schemeClr val="tx1"/>
                 </a:solidFill>
               </a:rPr>
               <a:t>Signed release APKs: the till and nelo pay</a:t>
             </a:r>
-            <a:endParaRPr lang="en-US" sz="1400" dirty="0"/>
+            <a:endParaRPr lang="en-US" sz="1300" dirty="0"/>
           </a:p>
           <a:p>
             <a:pPr marL="342900" indent="-342900">
               <a:spcAft>
-                <a:spcPts val="800"/>
+                <a:spcPts val="600"/>
               </a:spcAft>
               <a:buSzPct val="100000"/>
               <a:buChar char="•"/>
             </a:pPr>
             <a:r>
-              <a:rPr lang="en-US" sz="1400" dirty="0">
+              <a:rPr lang="en-US" sz="1300" dirty="0">
                 <a:solidFill>
                   <a:schemeClr val="tx1"/>
                 </a:solidFill>
               </a:rPr>
               <a:t>Mobile Wallet Adapter for every merchant signature</a:t>
             </a:r>
-            <a:endParaRPr lang="en-US" sz="1400" dirty="0"/>
+            <a:endParaRPr lang="en-US" sz="1300" dirty="0"/>
           </a:p>
           <a:p>
             <a:pPr marL="342900" indent="-342900">
               <a:spcAft>
-                <a:spcPts val="800"/>
+                <a:spcPts val="600"/>
               </a:spcAft>
               <a:buSzPct val="100000"/>
               <a:buChar char="•"/>
             </a:pPr>
             <a:r>
-              <a:rPr lang="en-US" sz="1400" dirty="0">
+              <a:rPr lang="en-US" sz="1300" dirty="0">
                 <a:solidFill>
                   <a:schemeClr val="tx1"/>
                 </a:solidFill>
               </a:rPr>
               <a:t>paj.cash's live naira rate on the till</a:t>
             </a:r>
-            <a:endParaRPr lang="en-US" sz="1400" dirty="0"/>
+            <a:endParaRPr lang="en-US" sz="1300" dirty="0"/>
           </a:p>
         </p:txBody>
       </p:sp>
@@ -10032,8 +10032,8 @@
         </p:nvSpPr>
         <p:spPr>
           <a:xfrm>
-            <a:off x="4572000" y="2606040"/>
-            <a:ext cx="2971800" cy="3063240"/>
+            <a:off x="4572000" y="2560320"/>
+            <a:ext cx="2971800" cy="3154680"/>
           </a:xfrm>
           <a:prstGeom prst="rect">
             <a:avLst/>
@@ -10047,74 +10047,74 @@
           <a:p>
             <a:pPr marL="342900" indent="-342900">
               <a:spcAft>
-                <a:spcPts val="800"/>
+                <a:spcPts val="600"/>
               </a:spcAft>
               <a:buSzPct val="100000"/>
               <a:buChar char="•"/>
             </a:pPr>
             <a:r>
-              <a:rPr lang="en-US" sz="1400" dirty="0">
+              <a:rPr lang="en-US" sz="1300" dirty="0">
                 <a:solidFill>
                   <a:schemeClr val="tx1"/>
                 </a:solidFill>
               </a:rPr>
               <a:t>Vault program: secure-chip signatures verified on chain</a:t>
             </a:r>
-            <a:endParaRPr lang="en-US" sz="1400" dirty="0"/>
+            <a:endParaRPr lang="en-US" sz="1300" dirty="0"/>
           </a:p>
           <a:p>
             <a:pPr marL="342900" indent="-342900">
               <a:spcAft>
-                <a:spcPts val="800"/>
+                <a:spcPts val="600"/>
               </a:spcAft>
               <a:buSzPct val="100000"/>
               <a:buChar char="•"/>
             </a:pPr>
             <a:r>
-              <a:rPr lang="en-US" sz="1400" dirty="0">
+              <a:rPr lang="en-US" sz="1300" dirty="0">
                 <a:solidFill>
                   <a:schemeClr val="tx1"/>
                 </a:solidFill>
               </a:rPr>
               <a:t>Offline sale, both phones in airplane mode, settled on reconnect</a:t>
             </a:r>
-            <a:endParaRPr lang="en-US" sz="1400" dirty="0"/>
+            <a:endParaRPr lang="en-US" sz="1300" dirty="0"/>
           </a:p>
           <a:p>
             <a:pPr marL="342900" indent="-342900">
               <a:spcAft>
-                <a:spcPts val="800"/>
+                <a:spcPts val="600"/>
               </a:spcAft>
               <a:buSzPct val="100000"/>
               <a:buChar char="•"/>
             </a:pPr>
             <a:r>
-              <a:rPr lang="en-US" sz="1400" dirty="0">
+              <a:rPr lang="en-US" sz="1300" dirty="0">
                 <a:solidFill>
                   <a:schemeClr val="tx1"/>
                 </a:solidFill>
               </a:rPr>
               <a:t>Replay refused; a forged double spend freezes the vault</a:t>
             </a:r>
-            <a:endParaRPr lang="en-US" sz="1400" dirty="0"/>
+            <a:endParaRPr lang="en-US" sz="1300" dirty="0"/>
           </a:p>
           <a:p>
             <a:pPr marL="342900" indent="-342900">
               <a:spcAft>
-                <a:spcPts val="800"/>
+                <a:spcPts val="600"/>
               </a:spcAft>
               <a:buSzPct val="100000"/>
               <a:buChar char="•"/>
             </a:pPr>
             <a:r>
-              <a:rPr lang="en-US" sz="1400" dirty="0">
+              <a:rPr lang="en-US" sz="1300" dirty="0">
                 <a:solidFill>
                   <a:schemeClr val="tx1"/>
                 </a:solidFill>
               </a:rPr>
               <a:t>anchor test green: 40 of 40</a:t>
             </a:r>
-            <a:endParaRPr lang="en-US" sz="1400" dirty="0"/>
+            <a:endParaRPr lang="en-US" sz="1300" dirty="0"/>
           </a:p>
         </p:txBody>
       </p:sp>
@@ -10184,8 +10184,8 @@
         </p:nvSpPr>
         <p:spPr>
           <a:xfrm>
-            <a:off x="8321040" y="2606040"/>
-            <a:ext cx="2971800" cy="3063240"/>
+            <a:off x="8321040" y="2560320"/>
+            <a:ext cx="2971800" cy="3154680"/>
           </a:xfrm>
           <a:prstGeom prst="rect">
             <a:avLst/>
@@ -10199,74 +10199,92 @@
           <a:p>
             <a:pPr marL="342900" indent="-342900">
               <a:spcAft>
-                <a:spcPts val="800"/>
+                <a:spcPts val="600"/>
               </a:spcAft>
               <a:buSzPct val="100000"/>
               <a:buChar char="•"/>
             </a:pPr>
             <a:r>
-              <a:rPr lang="en-US" sz="1400" dirty="0">
+              <a:rPr lang="en-US" sz="1300" dirty="0">
                 <a:solidFill>
                   <a:schemeClr val="tx1"/>
                 </a:solidFill>
               </a:rPr>
               <a:t>nelo pay services beyond paying a friend</a:t>
             </a:r>
-            <a:endParaRPr lang="en-US" sz="1400" dirty="0"/>
+            <a:endParaRPr lang="en-US" sz="1300" dirty="0"/>
           </a:p>
           <a:p>
             <a:pPr marL="342900" indent="-342900">
               <a:spcAft>
-                <a:spcPts val="800"/>
+                <a:spcPts val="600"/>
               </a:spcAft>
               <a:buSzPct val="100000"/>
               <a:buChar char="•"/>
             </a:pPr>
             <a:r>
-              <a:rPr lang="en-US" sz="1400" dirty="0">
+              <a:rPr lang="en-US" sz="1300" dirty="0">
                 <a:solidFill>
                   <a:schemeClr val="tx1"/>
                 </a:solidFill>
               </a:rPr>
               <a:t>Rebate payout and the SKR premium (≈1.001×)</a:t>
             </a:r>
-            <a:endParaRPr lang="en-US" sz="1400" dirty="0"/>
+            <a:endParaRPr lang="en-US" sz="1300" dirty="0"/>
           </a:p>
           <a:p>
             <a:pPr marL="342900" indent="-342900">
               <a:spcAft>
-                <a:spcPts val="800"/>
+                <a:spcPts val="600"/>
               </a:spcAft>
               <a:buSzPct val="100000"/>
               <a:buChar char="•"/>
             </a:pPr>
             <a:r>
-              <a:rPr lang="en-US" sz="1400" dirty="0">
+              <a:rPr lang="en-US" sz="1300" dirty="0">
                 <a:solidFill>
                   <a:schemeClr val="tx1"/>
                 </a:solidFill>
               </a:rPr>
               <a:t>QR only; NFC not yet</a:t>
             </a:r>
-            <a:endParaRPr lang="en-US" sz="1400" dirty="0"/>
+            <a:endParaRPr lang="en-US" sz="1300" dirty="0"/>
           </a:p>
           <a:p>
             <a:pPr marL="342900" indent="-342900">
               <a:spcAft>
-                <a:spcPts val="800"/>
+                <a:spcPts val="600"/>
               </a:spcAft>
               <a:buSzPct val="100000"/>
               <a:buChar char="•"/>
             </a:pPr>
             <a:r>
-              <a:rPr lang="en-US" sz="1400" dirty="0">
+              <a:rPr lang="en-US" sz="1300" dirty="0">
                 <a:solidFill>
                   <a:schemeClr val="tx1"/>
                 </a:solidFill>
               </a:rPr>
               <a:t>UseAzza payouts: partner agreed, integration next</a:t>
             </a:r>
-            <a:endParaRPr lang="en-US" sz="1400" dirty="0"/>
+            <a:endParaRPr lang="en-US" sz="1300" dirty="0"/>
+          </a:p>
+          <a:p>
+            <a:pPr marL="342900" indent="-342900">
+              <a:spcAft>
+                <a:spcPts val="600"/>
+              </a:spcAft>
+              <a:buSzPct val="100000"/>
+              <a:buChar char="•"/>
+            </a:pPr>
+            <a:r>
+              <a:rPr lang="en-US" sz="1300" dirty="0">
+                <a:solidFill>
+                  <a:schemeClr val="tx1"/>
+                </a:solidFill>
+              </a:rPr>
+              <a:t>Phone-number sign-up off (Privy SMS for Nigeria)</a:t>
+            </a:r>
+            <a:endParaRPr lang="en-US" sz="1300" dirty="0"/>
           </a:p>
         </p:txBody>
       </p:sp>

</xml_diff>

<commit_message>
Deck: UseAzza is a payout partner live from day one, Nigeria first
UseAzza moves from 'declared' to 'Live' on 'What actually ran', next to
paj.cash. The market, roadmap and dependency lines say Nigeria first, then
the 9+ currencies UseAzza pays out in, and the video script says the same.
</commit_message>
<xml_diff>
--- a/docs/deck/nelo-deck.pptx
+++ b/docs/deck/nelo-deck.pptx
@@ -123,30 +123,30 @@
   <p:extLst>
     <p:ext uri="{521415D9-36F7-43E2-AB2F-B90AF26B5E84}">
       <p14:sectionLst xmlns:p14="http://schemas.microsoft.com/office/powerpoint/2010/main">
-        <p14:section name="Opening" id="{c8adf936-f669-daf5-9cc4-6933fb19fdbe}">
+        <p14:section name="Opening" id="{ad6bcc3b-69c8-6947-ec9a-4cabd8b6b7b3}">
           <p14:sldIdLst>
             <p14:sldId id="256"/>
           </p14:sldIdLst>
         </p14:section>
-        <p14:section name="Problem" id="{186b2bf5-dc54-8f00-91a3-5eec7db49e2e}">
+        <p14:section name="Problem" id="{28e1e0a1-84b8-0d6b-71bb-877fe1ad2d9e}">
           <p14:sldIdLst>
             <p14:sldId id="257"/>
             <p14:sldId id="258"/>
           </p14:sldIdLst>
         </p14:section>
-        <p14:section name="Product" id="{2e1b777e-d46a-650d-598b-8f9b4de84ffc}">
+        <p14:section name="Product" id="{2888e25c-3578-2ab3-3d6b-60dfed5c54ce}">
           <p14:sldIdLst>
             <p14:sldId id="259"/>
             <p14:sldId id="260"/>
           </p14:sldIdLst>
         </p14:section>
-        <p14:section name="Proof" id="{7c485117-a664-5c07-f2ce-3ff34ad6704b}">
+        <p14:section name="Proof" id="{b317f663-dcf2-dfd0-b385-67e8ee5945ee}">
           <p14:sldIdLst>
             <p14:sldId id="261"/>
             <p14:sldId id="262"/>
           </p14:sldIdLst>
         </p14:section>
-        <p14:section name="Business" id="{a7693e43-437d-9b41-7bd1-79427f7fc48f}">
+        <p14:section name="Business" id="{308d4d08-b7fc-b90c-cc4d-d06fde61421c}">
           <p14:sldIdLst>
             <p14:sldId id="263"/>
             <p14:sldId id="264"/>
@@ -157,7 +157,7 @@
             <p14:sldId id="269"/>
           </p14:sldIdLst>
         </p14:section>
-        <p14:section name="Close" id="{7a184e24-4501-bd4e-e601-f41beb1e4817}">
+        <p14:section name="Close" id="{8c984572-f32f-ae5d-d7c8-bddfa73f3090}">
           <p14:sldIdLst>
             <p14:sldId id="270"/>
             <p14:sldId id="271"/>
@@ -9964,86 +9964,6 @@
             </a:r>
             <a:endParaRPr lang="en-US" sz="1300" dirty="0"/>
           </a:p>
-        </p:txBody>
-      </p:sp>
-      <p:sp>
-        <p:nvSpPr>
-          <p:cNvPr id="7" name="column"/>
-          <p:cNvSpPr/>
-          <p:nvPr/>
-        </p:nvSpPr>
-        <p:spPr>
-          <a:xfrm>
-            <a:off x="4297680" y="1874520"/>
-            <a:ext cx="3474720" cy="3931920"/>
-          </a:xfrm>
-          <a:prstGeom prst="roundRect">
-            <a:avLst>
-              <a:gd name="adj" fmla="val 5789"/>
-            </a:avLst>
-          </a:prstGeom>
-          <a:solidFill>
-            <a:srgbClr val="FFFFFF"/>
-          </a:solidFill>
-          <a:ln/>
-        </p:spPr>
-      </p:sp>
-      <p:sp>
-        <p:nvSpPr>
-          <p:cNvPr id="8" name="Text 6"/>
-          <p:cNvSpPr txBox="1"/>
-          <p:nvPr/>
-        </p:nvSpPr>
-        <p:spPr>
-          <a:xfrm>
-            <a:off x="4572000" y="2057400"/>
-            <a:ext cx="2926080" cy="457200"/>
-          </a:xfrm>
-          <a:prstGeom prst="rect">
-            <a:avLst/>
-          </a:prstGeom>
-          <a:noFill/>
-          <a:ln/>
-        </p:spPr>
-        <p:txBody>
-          <a:bodyPr wrap="square" lIns="0" tIns="0" rIns="0" bIns="0" rtlCol="0" anchor="t"/>
-          <a:lstStyle/>
-          <a:p>
-            <a:pPr indent="0" marL="0">
-              <a:buNone/>
-            </a:pPr>
-            <a:r>
-              <a:rPr lang="en-US" sz="2000" b="1" dirty="0">
-                <a:solidFill>
-                  <a:srgbClr val="9C4FC9"/>
-                </a:solidFill>
-              </a:rPr>
-              <a:t>On devnet</a:t>
-            </a:r>
-            <a:endParaRPr lang="en-US" sz="2000" dirty="0"/>
-          </a:p>
-        </p:txBody>
-      </p:sp>
-      <p:sp>
-        <p:nvSpPr>
-          <p:cNvPr id="9" name="Text 7"/>
-          <p:cNvSpPr txBox="1"/>
-          <p:nvPr/>
-        </p:nvSpPr>
-        <p:spPr>
-          <a:xfrm>
-            <a:off x="4572000" y="2560320"/>
-            <a:ext cx="2971800" cy="3154680"/>
-          </a:xfrm>
-          <a:prstGeom prst="rect">
-            <a:avLst/>
-          </a:prstGeom>
-          <a:noFill/>
-          <a:ln/>
-        </p:spPr>
-        <p:txBody>
-          <a:bodyPr wrap="square" lIns="0" tIns="0" rIns="0" bIns="0" rtlCol="0" anchor="t"/>
-          <a:lstStyle/>
           <a:p>
             <a:pPr marL="342900" indent="-342900">
               <a:spcAft>
@@ -10058,10 +9978,90 @@
                   <a:schemeClr val="tx1"/>
                 </a:solidFill>
               </a:rPr>
-              <a:t>Vault program: secure-chip signatures verified on chain</a:t>
+              <a:t>Payout partners from day one: paj.cash and UseAzza (9+ currencies)</a:t>
             </a:r>
             <a:endParaRPr lang="en-US" sz="1300" dirty="0"/>
           </a:p>
+        </p:txBody>
+      </p:sp>
+      <p:sp>
+        <p:nvSpPr>
+          <p:cNvPr id="7" name="column"/>
+          <p:cNvSpPr/>
+          <p:nvPr/>
+        </p:nvSpPr>
+        <p:spPr>
+          <a:xfrm>
+            <a:off x="4297680" y="1874520"/>
+            <a:ext cx="3474720" cy="3931920"/>
+          </a:xfrm>
+          <a:prstGeom prst="roundRect">
+            <a:avLst>
+              <a:gd name="adj" fmla="val 5789"/>
+            </a:avLst>
+          </a:prstGeom>
+          <a:solidFill>
+            <a:srgbClr val="FFFFFF"/>
+          </a:solidFill>
+          <a:ln/>
+        </p:spPr>
+      </p:sp>
+      <p:sp>
+        <p:nvSpPr>
+          <p:cNvPr id="8" name="Text 6"/>
+          <p:cNvSpPr txBox="1"/>
+          <p:nvPr/>
+        </p:nvSpPr>
+        <p:spPr>
+          <a:xfrm>
+            <a:off x="4572000" y="2057400"/>
+            <a:ext cx="2926080" cy="457200"/>
+          </a:xfrm>
+          <a:prstGeom prst="rect">
+            <a:avLst/>
+          </a:prstGeom>
+          <a:noFill/>
+          <a:ln/>
+        </p:spPr>
+        <p:txBody>
+          <a:bodyPr wrap="square" lIns="0" tIns="0" rIns="0" bIns="0" rtlCol="0" anchor="t"/>
+          <a:lstStyle/>
+          <a:p>
+            <a:pPr indent="0" marL="0">
+              <a:buNone/>
+            </a:pPr>
+            <a:r>
+              <a:rPr lang="en-US" sz="2000" b="1" dirty="0">
+                <a:solidFill>
+                  <a:srgbClr val="9C4FC9"/>
+                </a:solidFill>
+              </a:rPr>
+              <a:t>On devnet</a:t>
+            </a:r>
+            <a:endParaRPr lang="en-US" sz="2000" dirty="0"/>
+          </a:p>
+        </p:txBody>
+      </p:sp>
+      <p:sp>
+        <p:nvSpPr>
+          <p:cNvPr id="9" name="Text 7"/>
+          <p:cNvSpPr txBox="1"/>
+          <p:nvPr/>
+        </p:nvSpPr>
+        <p:spPr>
+          <a:xfrm>
+            <a:off x="4572000" y="2560320"/>
+            <a:ext cx="2971800" cy="3154680"/>
+          </a:xfrm>
+          <a:prstGeom prst="rect">
+            <a:avLst/>
+          </a:prstGeom>
+          <a:noFill/>
+          <a:ln/>
+        </p:spPr>
+        <p:txBody>
+          <a:bodyPr wrap="square" lIns="0" tIns="0" rIns="0" bIns="0" rtlCol="0" anchor="t"/>
+          <a:lstStyle/>
           <a:p>
             <a:pPr marL="342900" indent="-342900">
               <a:spcAft>
@@ -10076,7 +10076,7 @@
                   <a:schemeClr val="tx1"/>
                 </a:solidFill>
               </a:rPr>
-              <a:t>Offline sale, both phones in airplane mode, settled on reconnect</a:t>
+              <a:t>Vault program: secure-chip signatures verified on chain</a:t>
             </a:r>
             <a:endParaRPr lang="en-US" sz="1300" dirty="0"/>
           </a:p>
@@ -10094,7 +10094,7 @@
                   <a:schemeClr val="tx1"/>
                 </a:solidFill>
               </a:rPr>
-              <a:t>Replay refused; a forged double spend freezes the vault</a:t>
+              <a:t>Offline sale, both phones in airplane mode, settled on reconnect</a:t>
             </a:r>
             <a:endParaRPr lang="en-US" sz="1300" dirty="0"/>
           </a:p>
@@ -10112,90 +10112,10 @@
                   <a:schemeClr val="tx1"/>
                 </a:solidFill>
               </a:rPr>
-              <a:t>anchor test green: 40 of 40</a:t>
+              <a:t>Replay refused; a forged double spend freezes the vault</a:t>
             </a:r>
             <a:endParaRPr lang="en-US" sz="1300" dirty="0"/>
           </a:p>
-        </p:txBody>
-      </p:sp>
-      <p:sp>
-        <p:nvSpPr>
-          <p:cNvPr id="10" name="column"/>
-          <p:cNvSpPr/>
-          <p:nvPr/>
-        </p:nvSpPr>
-        <p:spPr>
-          <a:xfrm>
-            <a:off x="8046720" y="1874520"/>
-            <a:ext cx="3474720" cy="3931920"/>
-          </a:xfrm>
-          <a:prstGeom prst="roundRect">
-            <a:avLst>
-              <a:gd name="adj" fmla="val 5789"/>
-            </a:avLst>
-          </a:prstGeom>
-          <a:solidFill>
-            <a:srgbClr val="FFFFFF"/>
-          </a:solidFill>
-          <a:ln/>
-        </p:spPr>
-      </p:sp>
-      <p:sp>
-        <p:nvSpPr>
-          <p:cNvPr id="11" name="Text 9"/>
-          <p:cNvSpPr txBox="1"/>
-          <p:nvPr/>
-        </p:nvSpPr>
-        <p:spPr>
-          <a:xfrm>
-            <a:off x="8321040" y="2057400"/>
-            <a:ext cx="2926080" cy="457200"/>
-          </a:xfrm>
-          <a:prstGeom prst="rect">
-            <a:avLst/>
-          </a:prstGeom>
-          <a:noFill/>
-          <a:ln/>
-        </p:spPr>
-        <p:txBody>
-          <a:bodyPr wrap="square" lIns="0" tIns="0" rIns="0" bIns="0" rtlCol="0" anchor="t"/>
-          <a:lstStyle/>
-          <a:p>
-            <a:pPr indent="0" marL="0">
-              <a:buNone/>
-            </a:pPr>
-            <a:r>
-              <a:rPr lang="en-US" sz="2000" b="1" dirty="0">
-                <a:solidFill>
-                  <a:srgbClr val="C2560C"/>
-                </a:solidFill>
-              </a:rPr>
-              <a:t>Declared, not built yet</a:t>
-            </a:r>
-            <a:endParaRPr lang="en-US" sz="2000" dirty="0"/>
-          </a:p>
-        </p:txBody>
-      </p:sp>
-      <p:sp>
-        <p:nvSpPr>
-          <p:cNvPr id="12" name="Text 10"/>
-          <p:cNvSpPr txBox="1"/>
-          <p:nvPr/>
-        </p:nvSpPr>
-        <p:spPr>
-          <a:xfrm>
-            <a:off x="8321040" y="2560320"/>
-            <a:ext cx="2971800" cy="3154680"/>
-          </a:xfrm>
-          <a:prstGeom prst="rect">
-            <a:avLst/>
-          </a:prstGeom>
-          <a:noFill/>
-          <a:ln/>
-        </p:spPr>
-        <p:txBody>
-          <a:bodyPr wrap="square" lIns="0" tIns="0" rIns="0" bIns="0" rtlCol="0" anchor="t"/>
-          <a:lstStyle/>
           <a:p>
             <a:pPr marL="342900" indent="-342900">
               <a:spcAft>
@@ -10210,10 +10130,90 @@
                   <a:schemeClr val="tx1"/>
                 </a:solidFill>
               </a:rPr>
-              <a:t>nelo pay services beyond paying a friend</a:t>
+              <a:t>anchor test green: 40 of 40</a:t>
             </a:r>
             <a:endParaRPr lang="en-US" sz="1300" dirty="0"/>
           </a:p>
+        </p:txBody>
+      </p:sp>
+      <p:sp>
+        <p:nvSpPr>
+          <p:cNvPr id="10" name="column"/>
+          <p:cNvSpPr/>
+          <p:nvPr/>
+        </p:nvSpPr>
+        <p:spPr>
+          <a:xfrm>
+            <a:off x="8046720" y="1874520"/>
+            <a:ext cx="3474720" cy="3931920"/>
+          </a:xfrm>
+          <a:prstGeom prst="roundRect">
+            <a:avLst>
+              <a:gd name="adj" fmla="val 5789"/>
+            </a:avLst>
+          </a:prstGeom>
+          <a:solidFill>
+            <a:srgbClr val="FFFFFF"/>
+          </a:solidFill>
+          <a:ln/>
+        </p:spPr>
+      </p:sp>
+      <p:sp>
+        <p:nvSpPr>
+          <p:cNvPr id="11" name="Text 9"/>
+          <p:cNvSpPr txBox="1"/>
+          <p:nvPr/>
+        </p:nvSpPr>
+        <p:spPr>
+          <a:xfrm>
+            <a:off x="8321040" y="2057400"/>
+            <a:ext cx="2926080" cy="457200"/>
+          </a:xfrm>
+          <a:prstGeom prst="rect">
+            <a:avLst/>
+          </a:prstGeom>
+          <a:noFill/>
+          <a:ln/>
+        </p:spPr>
+        <p:txBody>
+          <a:bodyPr wrap="square" lIns="0" tIns="0" rIns="0" bIns="0" rtlCol="0" anchor="t"/>
+          <a:lstStyle/>
+          <a:p>
+            <a:pPr indent="0" marL="0">
+              <a:buNone/>
+            </a:pPr>
+            <a:r>
+              <a:rPr lang="en-US" sz="2000" b="1" dirty="0">
+                <a:solidFill>
+                  <a:srgbClr val="C2560C"/>
+                </a:solidFill>
+              </a:rPr>
+              <a:t>Declared, not built yet</a:t>
+            </a:r>
+            <a:endParaRPr lang="en-US" sz="2000" dirty="0"/>
+          </a:p>
+        </p:txBody>
+      </p:sp>
+      <p:sp>
+        <p:nvSpPr>
+          <p:cNvPr id="12" name="Text 10"/>
+          <p:cNvSpPr txBox="1"/>
+          <p:nvPr/>
+        </p:nvSpPr>
+        <p:spPr>
+          <a:xfrm>
+            <a:off x="8321040" y="2560320"/>
+            <a:ext cx="2971800" cy="3154680"/>
+          </a:xfrm>
+          <a:prstGeom prst="rect">
+            <a:avLst/>
+          </a:prstGeom>
+          <a:noFill/>
+          <a:ln/>
+        </p:spPr>
+        <p:txBody>
+          <a:bodyPr wrap="square" lIns="0" tIns="0" rIns="0" bIns="0" rtlCol="0" anchor="t"/>
+          <a:lstStyle/>
           <a:p>
             <a:pPr marL="342900" indent="-342900">
               <a:spcAft>
@@ -10228,7 +10228,7 @@
                   <a:schemeClr val="tx1"/>
                 </a:solidFill>
               </a:rPr>
-              <a:t>Rebate payout and the SKR premium (≈1.001×)</a:t>
+              <a:t>nelo pay services beyond paying a friend</a:t>
             </a:r>
             <a:endParaRPr lang="en-US" sz="1300" dirty="0"/>
           </a:p>
@@ -10246,7 +10246,7 @@
                   <a:schemeClr val="tx1"/>
                 </a:solidFill>
               </a:rPr>
-              <a:t>QR only; NFC not yet</a:t>
+              <a:t>Rebate payout and the SKR premium (≈1.001×)</a:t>
             </a:r>
             <a:endParaRPr lang="en-US" sz="1300" dirty="0"/>
           </a:p>
@@ -10264,7 +10264,7 @@
                   <a:schemeClr val="tx1"/>
                 </a:solidFill>
               </a:rPr>
-              <a:t>UseAzza payouts: partner agreed, integration next</a:t>
+              <a:t>QR only; NFC not yet</a:t>
             </a:r>
             <a:endParaRPr lang="en-US" sz="1300" dirty="0"/>
           </a:p>
@@ -10631,7 +10631,7 @@
                   <a:schemeClr val="accent6"/>
                 </a:solidFill>
               </a:rPr>
-              <a:t>dApp Store listing. One market cluster, door to door. Cash-outs through paj.cash.</a:t>
+              <a:t>dApp Store listing. One market cluster in Nigeria, door to door. Cash-outs through paj.cash and UseAzza.</a:t>
             </a:r>
             <a:endParaRPr lang="en-US" sz="1400" dirty="0"/>
           </a:p>
@@ -11088,7 +11088,7 @@
                   <a:schemeClr val="accent1"/>
                 </a:solidFill>
               </a:rPr>
-              <a:t>Payout partners were the one blocking dependency. paj.cash is live for naira; UseAzza brings 9+ more payout currencies.</a:t>
+              <a:t>Payout partners were the one blocking dependency. paj.cash and UseAzza are live from day one: Nigeria first, then 9+ more currencies.</a:t>
             </a:r>
             <a:endParaRPr lang="en-US" sz="1500" dirty="0"/>
           </a:p>
@@ -16152,7 +16152,7 @@
                   <a:schemeClr val="bg1"/>
                 </a:solidFill>
               </a:rPr>
-              <a:t>≈3% of TAM: in-person business payments in the 10+ currencies paj.cash and UseAzza pay out in</a:t>
+              <a:t>≈3% of TAM: in-person business payments, Nigeria first, then the 9+ currencies UseAzza pays out in</a:t>
             </a:r>
             <a:endParaRPr lang="en-US" sz="1100" dirty="0"/>
           </a:p>

</xml_diff>